<commit_message>
Refine three-slide presentation theme
</commit_message>
<xml_diff>
--- a/presentation/GP_40_DonorInterval.pptx
+++ b/presentation/GP_40_DonorInterval.pptx
@@ -3086,7 +3086,7 @@
     <p:bg>
       <p:bgPr>
         <a:solidFill>
-          <a:srgbClr val="FFFFFF"/>
+          <a:srgbClr val="F8FAFB"/>
         </a:solidFill>
         <a:effectLst/>
       </p:bgPr>
@@ -3107,13 +3107,13 @@
         <p:spPr>
           <a:xfrm>
             <a:off x="0" y="0"/>
-            <a:ext cx="12191695" cy="118872"/>
+            <a:ext cx="118872" cy="6858000"/>
           </a:xfrm>
           <a:prstGeom prst="rect">
             <a:avLst/>
           </a:prstGeom>
           <a:solidFill>
-            <a:srgbClr val="1B5B97"/>
+            <a:srgbClr val="157E74"/>
           </a:solidFill>
           <a:ln>
             <a:noFill/>
@@ -3149,8 +3149,8 @@
         </p:nvSpPr>
         <p:spPr>
           <a:xfrm>
-            <a:off x="640080" y="283464"/>
-            <a:ext cx="7772400" cy="274320"/>
+            <a:off x="667512" y="320040"/>
+            <a:ext cx="7315200" cy="246888"/>
           </a:xfrm>
           <a:prstGeom prst="rect">
             <a:avLst/>
@@ -3164,35 +3164,71 @@
           <a:lstStyle/>
           <a:p>
             <a:pPr algn="l">
-              <a:defRPr sz="1100" b="1">
-                <a:solidFill>
-                  <a:srgbClr val="1B5B97"/>
-                </a:solidFill>
-                <a:latin typeface="Aptos"/>
+              <a:defRPr sz="1000" b="1">
+                <a:solidFill>
+                  <a:srgbClr val="1C5484"/>
+                </a:solidFill>
+                <a:latin typeface="Segoe UI"/>
               </a:defRPr>
             </a:pPr>
             <a:r>
-              <a:t>EC8204  |  BLOCKCHAIN AND CYBER SECURITY</a:t>
-            </a:r>
-          </a:p>
-        </p:txBody>
-      </p:sp>
-      <p:sp>
-        <p:nvSpPr>
-          <p:cNvPr id="4" name="Rectangle 3"/>
+              <a:t>EC8204  /  BLOCKCHAIN AND CYBER SECURITY</a:t>
+            </a:r>
+          </a:p>
+        </p:txBody>
+      </p:sp>
+      <p:sp>
+        <p:nvSpPr>
+          <p:cNvPr id="4" name="TextBox 3"/>
+          <p:cNvSpPr txBox="1"/>
+          <p:nvPr/>
+        </p:nvSpPr>
+        <p:spPr>
+          <a:xfrm>
+            <a:off x="9418320" y="320040"/>
+            <a:ext cx="2103120" cy="246888"/>
+          </a:xfrm>
+          <a:prstGeom prst="rect">
+            <a:avLst/>
+          </a:prstGeom>
+          <a:noFill/>
+        </p:spPr>
+        <p:txBody>
+          <a:bodyPr wrap="square" lIns="18288" rIns="18288" tIns="9144" bIns="9144">
+            <a:spAutoFit/>
+          </a:bodyPr>
+          <a:lstStyle/>
+          <a:p>
+            <a:pPr algn="r">
+              <a:defRPr sz="1000" b="1">
+                <a:solidFill>
+                  <a:srgbClr val="667684"/>
+                </a:solidFill>
+                <a:latin typeface="Segoe UI"/>
+              </a:defRPr>
+            </a:pPr>
+            <a:r>
+              <a:t>INTRODUCTION</a:t>
+            </a:r>
+          </a:p>
+        </p:txBody>
+      </p:sp>
+      <p:sp>
+        <p:nvSpPr>
+          <p:cNvPr id="5" name="Rectangle 4"/>
           <p:cNvSpPr/>
           <p:nvPr/>
         </p:nvSpPr>
         <p:spPr>
           <a:xfrm>
-            <a:off x="640080" y="6419088"/>
-            <a:ext cx="10881360" cy="10972"/>
+            <a:off x="685800" y="6336792"/>
+            <a:ext cx="10835640" cy="13716"/>
           </a:xfrm>
           <a:prstGeom prst="rect">
             <a:avLst/>
           </a:prstGeom>
           <a:solidFill>
-            <a:srgbClr val="D5DEE6"/>
+            <a:srgbClr val="D7E0E7"/>
           </a:solidFill>
           <a:ln>
             <a:noFill/>
@@ -3222,14 +3258,14 @@
       </p:sp>
       <p:sp>
         <p:nvSpPr>
-          <p:cNvPr id="5" name="TextBox 4"/>
+          <p:cNvPr id="6" name="TextBox 5"/>
           <p:cNvSpPr txBox="1"/>
           <p:nvPr/>
         </p:nvSpPr>
         <p:spPr>
           <a:xfrm>
-            <a:off x="658368" y="6473952"/>
-            <a:ext cx="5486400" cy="210312"/>
+            <a:off x="694944" y="6437376"/>
+            <a:ext cx="5303520" cy="210312"/>
           </a:xfrm>
           <a:prstGeom prst="rect">
             <a:avLst/>
@@ -3245,27 +3281,27 @@
             <a:pPr algn="l">
               <a:defRPr sz="900" b="0">
                 <a:solidFill>
-                  <a:srgbClr val="616F7C"/>
-                </a:solidFill>
-                <a:latin typeface="Aptos"/>
+                  <a:srgbClr val="667684"/>
+                </a:solidFill>
+                <a:latin typeface="Segoe UI"/>
               </a:defRPr>
             </a:pPr>
             <a:r>
-              <a:t>GROUP 40  |  DONORINTERVAL</a:t>
-            </a:r>
-          </a:p>
-        </p:txBody>
-      </p:sp>
-      <p:sp>
-        <p:nvSpPr>
-          <p:cNvPr id="6" name="TextBox 5"/>
+              <a:t>GROUP 40 · DONORINTERVAL</a:t>
+            </a:r>
+          </a:p>
+        </p:txBody>
+      </p:sp>
+      <p:sp>
+        <p:nvSpPr>
+          <p:cNvPr id="7" name="TextBox 6"/>
           <p:cNvSpPr txBox="1"/>
           <p:nvPr/>
         </p:nvSpPr>
         <p:spPr>
           <a:xfrm>
-            <a:off x="10972800" y="6473952"/>
-            <a:ext cx="502920" cy="210312"/>
+            <a:off x="10789920" y="6437376"/>
+            <a:ext cx="731520" cy="210312"/>
           </a:xfrm>
           <a:prstGeom prst="rect">
             <a:avLst/>
@@ -3281,27 +3317,27 @@
             <a:pPr algn="r">
               <a:defRPr sz="900" b="0">
                 <a:solidFill>
-                  <a:srgbClr val="616F7C"/>
-                </a:solidFill>
-                <a:latin typeface="Aptos"/>
+                  <a:srgbClr val="667684"/>
+                </a:solidFill>
+                <a:latin typeface="Segoe UI"/>
               </a:defRPr>
             </a:pPr>
             <a:r>
-              <a:t>1</a:t>
-            </a:r>
-          </a:p>
-        </p:txBody>
-      </p:sp>
-      <p:sp>
-        <p:nvSpPr>
-          <p:cNvPr id="7" name="TextBox 6"/>
+              <a:t>01 / 03</a:t>
+            </a:r>
+          </a:p>
+        </p:txBody>
+      </p:sp>
+      <p:sp>
+        <p:nvSpPr>
+          <p:cNvPr id="8" name="TextBox 7"/>
           <p:cNvSpPr txBox="1"/>
           <p:nvPr/>
         </p:nvSpPr>
         <p:spPr>
           <a:xfrm>
-            <a:off x="658368" y="1170432"/>
-            <a:ext cx="10607040" cy="713232"/>
+            <a:off x="713232" y="1143000"/>
+            <a:ext cx="6675120" cy="731520"/>
           </a:xfrm>
           <a:prstGeom prst="rect">
             <a:avLst/>
@@ -3315,11 +3351,11 @@
           <a:lstStyle/>
           <a:p>
             <a:pPr algn="l">
-              <a:defRPr sz="3800" b="1">
-                <a:solidFill>
-                  <a:srgbClr val="193048"/>
-                </a:solidFill>
-                <a:latin typeface="Aptos"/>
+              <a:defRPr sz="4400" b="1">
+                <a:solidFill>
+                  <a:srgbClr val="163045"/>
+                </a:solidFill>
+                <a:latin typeface="Segoe UI"/>
               </a:defRPr>
             </a:pPr>
             <a:r>
@@ -3330,14 +3366,14 @@
       </p:sp>
       <p:sp>
         <p:nvSpPr>
-          <p:cNvPr id="8" name="TextBox 7"/>
+          <p:cNvPr id="9" name="TextBox 8"/>
           <p:cNvSpPr txBox="1"/>
           <p:nvPr/>
         </p:nvSpPr>
         <p:spPr>
           <a:xfrm>
-            <a:off x="685800" y="1975104"/>
-            <a:ext cx="10515600" cy="457200"/>
+            <a:off x="749808" y="1975104"/>
+            <a:ext cx="6766560" cy="429768"/>
           </a:xfrm>
           <a:prstGeom prst="rect">
             <a:avLst/>
@@ -3353,33 +3389,33 @@
             <a:pPr algn="l">
               <a:defRPr sz="2400" b="0">
                 <a:solidFill>
-                  <a:srgbClr val="1B5B97"/>
-                </a:solidFill>
-                <a:latin typeface="Aptos"/>
+                  <a:srgbClr val="1C5484"/>
+                </a:solidFill>
+                <a:latin typeface="Segoe UI"/>
               </a:defRPr>
             </a:pPr>
             <a:r>
-              <a:t>Blockchain-based blood donation interval registry</a:t>
-            </a:r>
-          </a:p>
-        </p:txBody>
-      </p:sp>
-      <p:sp>
-        <p:nvSpPr>
-          <p:cNvPr id="9" name="Rectangle 8"/>
+              <a:t>Blood donation interval registry</a:t>
+            </a:r>
+          </a:p>
+        </p:txBody>
+      </p:sp>
+      <p:sp>
+        <p:nvSpPr>
+          <p:cNvPr id="10" name="Rectangle 9"/>
           <p:cNvSpPr/>
           <p:nvPr/>
         </p:nvSpPr>
         <p:spPr>
           <a:xfrm>
-            <a:off x="685800" y="2770632"/>
-            <a:ext cx="10607040" cy="22860"/>
+            <a:off x="749808" y="2761488"/>
+            <a:ext cx="731520" cy="41148"/>
           </a:xfrm>
           <a:prstGeom prst="rect">
             <a:avLst/>
           </a:prstGeom>
           <a:solidFill>
-            <a:srgbClr val="D5DEE6"/>
+            <a:srgbClr val="157E74"/>
           </a:solidFill>
           <a:ln>
             <a:noFill/>
@@ -3409,14 +3445,14 @@
       </p:sp>
       <p:sp>
         <p:nvSpPr>
-          <p:cNvPr id="10" name="TextBox 9"/>
+          <p:cNvPr id="11" name="TextBox 10"/>
           <p:cNvSpPr txBox="1"/>
           <p:nvPr/>
         </p:nvSpPr>
         <p:spPr>
           <a:xfrm>
-            <a:off x="685800" y="3136392"/>
-            <a:ext cx="1371600" cy="365760"/>
+            <a:off x="749808" y="3118104"/>
+            <a:ext cx="6400800" cy="1024128"/>
           </a:xfrm>
           <a:prstGeom prst="rect">
             <a:avLst/>
@@ -3430,29 +3466,29 @@
           <a:lstStyle/>
           <a:p>
             <a:pPr algn="l">
-              <a:defRPr sz="1700" b="1">
-                <a:solidFill>
-                  <a:srgbClr val="193048"/>
-                </a:solidFill>
-                <a:latin typeface="Aptos"/>
+              <a:defRPr sz="2200" b="0">
+                <a:solidFill>
+                  <a:srgbClr val="2A3A48"/>
+                </a:solidFill>
+                <a:latin typeface="Segoe UI"/>
               </a:defRPr>
             </a:pPr>
             <a:r>
-              <a:t>Problem</a:t>
-            </a:r>
-          </a:p>
-        </p:txBody>
-      </p:sp>
-      <p:sp>
-        <p:nvSpPr>
-          <p:cNvPr id="11" name="TextBox 10"/>
+              <a:t>A shared record of donation timing for participating blood banks.</a:t>
+            </a:r>
+          </a:p>
+        </p:txBody>
+      </p:sp>
+      <p:sp>
+        <p:nvSpPr>
+          <p:cNvPr id="12" name="TextBox 11"/>
           <p:cNvSpPr txBox="1"/>
           <p:nvPr/>
         </p:nvSpPr>
         <p:spPr>
           <a:xfrm>
-            <a:off x="2148840" y="3108960"/>
-            <a:ext cx="8686800" cy="822960"/>
+            <a:off x="749808" y="4809744"/>
+            <a:ext cx="2011680" cy="301752"/>
           </a:xfrm>
           <a:prstGeom prst="rect">
             <a:avLst/>
@@ -3466,29 +3502,29 @@
           <a:lstStyle/>
           <a:p>
             <a:pPr algn="l">
-              <a:defRPr sz="2100" b="0">
-                <a:solidFill>
-                  <a:srgbClr val="2F3A46"/>
-                </a:solidFill>
-                <a:latin typeface="Aptos"/>
+              <a:defRPr sz="1400" b="1">
+                <a:solidFill>
+                  <a:srgbClr val="157E74"/>
+                </a:solidFill>
+                <a:latin typeface="Segoe UI"/>
               </a:defRPr>
             </a:pPr>
             <a:r>
-              <a:t>A blood bank may not see a recent donation recorded by another participating bank.</a:t>
-            </a:r>
-          </a:p>
-        </p:txBody>
-      </p:sp>
-      <p:sp>
-        <p:nvSpPr>
-          <p:cNvPr id="12" name="TextBox 11"/>
+              <a:t>GROUP 40</a:t>
+            </a:r>
+          </a:p>
+        </p:txBody>
+      </p:sp>
+      <p:sp>
+        <p:nvSpPr>
+          <p:cNvPr id="13" name="TextBox 12"/>
           <p:cNvSpPr txBox="1"/>
           <p:nvPr/>
         </p:nvSpPr>
         <p:spPr>
           <a:xfrm>
-            <a:off x="685800" y="4681728"/>
-            <a:ext cx="2286000" cy="347472"/>
+            <a:off x="749808" y="5230368"/>
+            <a:ext cx="6949440" cy="365760"/>
           </a:xfrm>
           <a:prstGeom prst="rect">
             <a:avLst/>
@@ -3502,29 +3538,72 @@
           <a:lstStyle/>
           <a:p>
             <a:pPr algn="l">
-              <a:defRPr sz="1600" b="1">
-                <a:solidFill>
-                  <a:srgbClr val="193048"/>
-                </a:solidFill>
-                <a:latin typeface="Aptos"/>
+              <a:defRPr sz="1700" b="0">
+                <a:solidFill>
+                  <a:srgbClr val="163045"/>
+                </a:solidFill>
+                <a:latin typeface="Segoe UI"/>
               </a:defRPr>
             </a:pPr>
             <a:r>
-              <a:t>Group 40</a:t>
-            </a:r>
-          </a:p>
-        </p:txBody>
-      </p:sp>
-      <p:sp>
-        <p:nvSpPr>
-          <p:cNvPr id="13" name="TextBox 12"/>
+              <a:t>Member 1   |   Member 2   |   Member 3</a:t>
+            </a:r>
+          </a:p>
+        </p:txBody>
+      </p:sp>
+      <p:sp>
+        <p:nvSpPr>
+          <p:cNvPr id="14" name="Rectangle 13"/>
+          <p:cNvSpPr/>
+          <p:nvPr/>
+        </p:nvSpPr>
+        <p:spPr>
+          <a:xfrm>
+            <a:off x="7973568" y="1069848"/>
+            <a:ext cx="3520440" cy="4553712"/>
+          </a:xfrm>
+          <a:prstGeom prst="rect">
+            <a:avLst/>
+          </a:prstGeom>
+          <a:solidFill>
+            <a:srgbClr val="E8F0F8"/>
+          </a:solidFill>
+          <a:ln>
+            <a:noFill/>
+          </a:ln>
+        </p:spPr>
+        <p:style>
+          <a:lnRef idx="1">
+            <a:schemeClr val="accent1"/>
+          </a:lnRef>
+          <a:fillRef idx="3">
+            <a:schemeClr val="accent1"/>
+          </a:fillRef>
+          <a:effectRef idx="2">
+            <a:schemeClr val="accent1"/>
+          </a:effectRef>
+          <a:fontRef idx="minor">
+            <a:schemeClr val="lt1"/>
+          </a:fontRef>
+        </p:style>
+        <p:txBody>
+          <a:bodyPr rtlCol="0" anchor="ctr"/>
+          <a:lstStyle/>
+          <a:p>
+            <a:pPr algn="ctr"/>
+          </a:p>
+        </p:txBody>
+      </p:sp>
+      <p:sp>
+        <p:nvSpPr>
+          <p:cNvPr id="15" name="TextBox 14"/>
           <p:cNvSpPr txBox="1"/>
           <p:nvPr/>
         </p:nvSpPr>
         <p:spPr>
           <a:xfrm>
-            <a:off x="685800" y="5138928"/>
-            <a:ext cx="10789920" cy="411480"/>
+            <a:off x="8266175" y="1481328"/>
+            <a:ext cx="2880360" cy="320040"/>
           </a:xfrm>
           <a:prstGeom prst="rect">
             <a:avLst/>
@@ -3538,29 +3617,72 @@
           <a:lstStyle/>
           <a:p>
             <a:pPr algn="l">
-              <a:defRPr sz="1800" b="0">
-                <a:solidFill>
-                  <a:srgbClr val="2F3A46"/>
-                </a:solidFill>
-                <a:latin typeface="Aptos"/>
+              <a:defRPr sz="1500" b="1">
+                <a:solidFill>
+                  <a:srgbClr val="1C5484"/>
+                </a:solidFill>
+                <a:latin typeface="Segoe UI"/>
               </a:defRPr>
             </a:pPr>
             <a:r>
-              <a:t>Member 1   |   Member 2   |   Member 3</a:t>
-            </a:r>
-          </a:p>
-        </p:txBody>
-      </p:sp>
-      <p:sp>
-        <p:nvSpPr>
-          <p:cNvPr id="14" name="TextBox 13"/>
+              <a:t>THE PROBLEM</a:t>
+            </a:r>
+          </a:p>
+        </p:txBody>
+      </p:sp>
+      <p:sp>
+        <p:nvSpPr>
+          <p:cNvPr id="16" name="Rectangle 15"/>
+          <p:cNvSpPr/>
+          <p:nvPr/>
+        </p:nvSpPr>
+        <p:spPr>
+          <a:xfrm>
+            <a:off x="8266175" y="2029968"/>
+            <a:ext cx="438912" cy="32004"/>
+          </a:xfrm>
+          <a:prstGeom prst="rect">
+            <a:avLst/>
+          </a:prstGeom>
+          <a:solidFill>
+            <a:srgbClr val="157E74"/>
+          </a:solidFill>
+          <a:ln>
+            <a:noFill/>
+          </a:ln>
+        </p:spPr>
+        <p:style>
+          <a:lnRef idx="1">
+            <a:schemeClr val="accent1"/>
+          </a:lnRef>
+          <a:fillRef idx="3">
+            <a:schemeClr val="accent1"/>
+          </a:fillRef>
+          <a:effectRef idx="2">
+            <a:schemeClr val="accent1"/>
+          </a:effectRef>
+          <a:fontRef idx="minor">
+            <a:schemeClr val="lt1"/>
+          </a:fontRef>
+        </p:style>
+        <p:txBody>
+          <a:bodyPr rtlCol="0" anchor="ctr"/>
+          <a:lstStyle/>
+          <a:p>
+            <a:pPr algn="ctr"/>
+          </a:p>
+        </p:txBody>
+      </p:sp>
+      <p:sp>
+        <p:nvSpPr>
+          <p:cNvPr id="17" name="TextBox 16"/>
           <p:cNvSpPr txBox="1"/>
           <p:nvPr/>
         </p:nvSpPr>
         <p:spPr>
           <a:xfrm>
-            <a:off x="685800" y="5788152"/>
-            <a:ext cx="10789920" cy="292608"/>
+            <a:off x="8266175" y="2331720"/>
+            <a:ext cx="2743200" cy="2240280"/>
           </a:xfrm>
           <a:prstGeom prst="rect">
             <a:avLst/>
@@ -3574,15 +3696,51 @@
           <a:lstStyle/>
           <a:p>
             <a:pPr algn="l">
-              <a:defRPr sz="1300" b="0">
-                <a:solidFill>
-                  <a:srgbClr val="616F7C"/>
-                </a:solidFill>
-                <a:latin typeface="Aptos"/>
+              <a:defRPr sz="2100" b="0">
+                <a:solidFill>
+                  <a:srgbClr val="163045"/>
+                </a:solidFill>
+                <a:latin typeface="Segoe UI"/>
               </a:defRPr>
             </a:pPr>
             <a:r>
-              <a:t>Source: github.com/Chathzaa/donor-interval</a:t>
+              <a:t>A recent donation may be visible at one bank but absent from another bank's records.</a:t>
+            </a:r>
+          </a:p>
+        </p:txBody>
+      </p:sp>
+      <p:sp>
+        <p:nvSpPr>
+          <p:cNvPr id="18" name="TextBox 17"/>
+          <p:cNvSpPr txBox="1"/>
+          <p:nvPr/>
+        </p:nvSpPr>
+        <p:spPr>
+          <a:xfrm>
+            <a:off x="749808" y="5916168"/>
+            <a:ext cx="9875520" cy="256032"/>
+          </a:xfrm>
+          <a:prstGeom prst="rect">
+            <a:avLst/>
+          </a:prstGeom>
+          <a:noFill/>
+        </p:spPr>
+        <p:txBody>
+          <a:bodyPr wrap="square" lIns="18288" rIns="18288" tIns="9144" bIns="9144">
+            <a:spAutoFit/>
+          </a:bodyPr>
+          <a:lstStyle/>
+          <a:p>
+            <a:pPr algn="l">
+              <a:defRPr sz="1100" b="0">
+                <a:solidFill>
+                  <a:srgbClr val="667684"/>
+                </a:solidFill>
+                <a:latin typeface="Segoe UI"/>
+              </a:defRPr>
+            </a:pPr>
+            <a:r>
+              <a:t>Source code: github.com/Chathzaa/donor-interval</a:t>
             </a:r>
           </a:p>
         </p:txBody>
@@ -3601,7 +3759,7 @@
     <p:bg>
       <p:bgPr>
         <a:solidFill>
-          <a:srgbClr val="FFFFFF"/>
+          <a:srgbClr val="F8FAFB"/>
         </a:solidFill>
         <a:effectLst/>
       </p:bgPr>
@@ -3622,13 +3780,13 @@
         <p:spPr>
           <a:xfrm>
             <a:off x="0" y="0"/>
-            <a:ext cx="12191695" cy="118872"/>
+            <a:ext cx="118872" cy="6858000"/>
           </a:xfrm>
           <a:prstGeom prst="rect">
             <a:avLst/>
           </a:prstGeom>
           <a:solidFill>
-            <a:srgbClr val="1B5B97"/>
+            <a:srgbClr val="157E74"/>
           </a:solidFill>
           <a:ln>
             <a:noFill/>
@@ -3664,8 +3822,8 @@
         </p:nvSpPr>
         <p:spPr>
           <a:xfrm>
-            <a:off x="640080" y="283464"/>
-            <a:ext cx="7772400" cy="274320"/>
+            <a:off x="667512" y="320040"/>
+            <a:ext cx="7315200" cy="246888"/>
           </a:xfrm>
           <a:prstGeom prst="rect">
             <a:avLst/>
@@ -3679,35 +3837,71 @@
           <a:lstStyle/>
           <a:p>
             <a:pPr algn="l">
-              <a:defRPr sz="1100" b="1">
-                <a:solidFill>
-                  <a:srgbClr val="1B5B97"/>
-                </a:solidFill>
-                <a:latin typeface="Aptos"/>
+              <a:defRPr sz="1000" b="1">
+                <a:solidFill>
+                  <a:srgbClr val="1C5484"/>
+                </a:solidFill>
+                <a:latin typeface="Segoe UI"/>
               </a:defRPr>
             </a:pPr>
             <a:r>
-              <a:t>EC8204  |  BLOCKCHAIN AND CYBER SECURITY</a:t>
-            </a:r>
-          </a:p>
-        </p:txBody>
-      </p:sp>
-      <p:sp>
-        <p:nvSpPr>
-          <p:cNvPr id="4" name="Rectangle 3"/>
+              <a:t>EC8204  /  BLOCKCHAIN AND CYBER SECURITY</a:t>
+            </a:r>
+          </a:p>
+        </p:txBody>
+      </p:sp>
+      <p:sp>
+        <p:nvSpPr>
+          <p:cNvPr id="4" name="TextBox 3"/>
+          <p:cNvSpPr txBox="1"/>
+          <p:nvPr/>
+        </p:nvSpPr>
+        <p:spPr>
+          <a:xfrm>
+            <a:off x="9418320" y="320040"/>
+            <a:ext cx="2103120" cy="246888"/>
+          </a:xfrm>
+          <a:prstGeom prst="rect">
+            <a:avLst/>
+          </a:prstGeom>
+          <a:noFill/>
+        </p:spPr>
+        <p:txBody>
+          <a:bodyPr wrap="square" lIns="18288" rIns="18288" tIns="9144" bIns="9144">
+            <a:spAutoFit/>
+          </a:bodyPr>
+          <a:lstStyle/>
+          <a:p>
+            <a:pPr algn="r">
+              <a:defRPr sz="1000" b="1">
+                <a:solidFill>
+                  <a:srgbClr val="667684"/>
+                </a:solidFill>
+                <a:latin typeface="Segoe UI"/>
+              </a:defRPr>
+            </a:pPr>
+            <a:r>
+              <a:t>DESIGN</a:t>
+            </a:r>
+          </a:p>
+        </p:txBody>
+      </p:sp>
+      <p:sp>
+        <p:nvSpPr>
+          <p:cNvPr id="5" name="Rectangle 4"/>
           <p:cNvSpPr/>
           <p:nvPr/>
         </p:nvSpPr>
         <p:spPr>
           <a:xfrm>
-            <a:off x="640080" y="6419088"/>
-            <a:ext cx="10881360" cy="10972"/>
+            <a:off x="685800" y="6336792"/>
+            <a:ext cx="10835640" cy="13716"/>
           </a:xfrm>
           <a:prstGeom prst="rect">
             <a:avLst/>
           </a:prstGeom>
           <a:solidFill>
-            <a:srgbClr val="D5DEE6"/>
+            <a:srgbClr val="D7E0E7"/>
           </a:solidFill>
           <a:ln>
             <a:noFill/>
@@ -3737,14 +3931,14 @@
       </p:sp>
       <p:sp>
         <p:nvSpPr>
-          <p:cNvPr id="5" name="TextBox 4"/>
+          <p:cNvPr id="6" name="TextBox 5"/>
           <p:cNvSpPr txBox="1"/>
           <p:nvPr/>
         </p:nvSpPr>
         <p:spPr>
           <a:xfrm>
-            <a:off x="658368" y="6473952"/>
-            <a:ext cx="5486400" cy="210312"/>
+            <a:off x="694944" y="6437376"/>
+            <a:ext cx="5303520" cy="210312"/>
           </a:xfrm>
           <a:prstGeom prst="rect">
             <a:avLst/>
@@ -3760,27 +3954,27 @@
             <a:pPr algn="l">
               <a:defRPr sz="900" b="0">
                 <a:solidFill>
-                  <a:srgbClr val="616F7C"/>
-                </a:solidFill>
-                <a:latin typeface="Aptos"/>
+                  <a:srgbClr val="667684"/>
+                </a:solidFill>
+                <a:latin typeface="Segoe UI"/>
               </a:defRPr>
             </a:pPr>
             <a:r>
-              <a:t>GROUP 40  |  DONORINTERVAL</a:t>
-            </a:r>
-          </a:p>
-        </p:txBody>
-      </p:sp>
-      <p:sp>
-        <p:nvSpPr>
-          <p:cNvPr id="6" name="TextBox 5"/>
+              <a:t>GROUP 40 · DONORINTERVAL</a:t>
+            </a:r>
+          </a:p>
+        </p:txBody>
+      </p:sp>
+      <p:sp>
+        <p:nvSpPr>
+          <p:cNvPr id="7" name="TextBox 6"/>
           <p:cNvSpPr txBox="1"/>
           <p:nvPr/>
         </p:nvSpPr>
         <p:spPr>
           <a:xfrm>
-            <a:off x="10972800" y="6473952"/>
-            <a:ext cx="502920" cy="210312"/>
+            <a:off x="10789920" y="6437376"/>
+            <a:ext cx="731520" cy="210312"/>
           </a:xfrm>
           <a:prstGeom prst="rect">
             <a:avLst/>
@@ -3796,27 +3990,27 @@
             <a:pPr algn="r">
               <a:defRPr sz="900" b="0">
                 <a:solidFill>
-                  <a:srgbClr val="616F7C"/>
-                </a:solidFill>
-                <a:latin typeface="Aptos"/>
+                  <a:srgbClr val="667684"/>
+                </a:solidFill>
+                <a:latin typeface="Segoe UI"/>
               </a:defRPr>
             </a:pPr>
             <a:r>
-              <a:t>2</a:t>
-            </a:r>
-          </a:p>
-        </p:txBody>
-      </p:sp>
-      <p:sp>
-        <p:nvSpPr>
-          <p:cNvPr id="7" name="TextBox 6"/>
+              <a:t>02 / 03</a:t>
+            </a:r>
+          </a:p>
+        </p:txBody>
+      </p:sp>
+      <p:sp>
+        <p:nvSpPr>
+          <p:cNvPr id="8" name="TextBox 7"/>
           <p:cNvSpPr txBox="1"/>
           <p:nvPr/>
         </p:nvSpPr>
         <p:spPr>
           <a:xfrm>
-            <a:off x="658368" y="786384"/>
-            <a:ext cx="10789920" cy="548640"/>
+            <a:off x="713232" y="905256"/>
+            <a:ext cx="10698480" cy="502920"/>
           </a:xfrm>
           <a:prstGeom prst="rect">
             <a:avLst/>
@@ -3832,37 +4026,73 @@
             <a:pPr algn="l">
               <a:defRPr sz="2900" b="1">
                 <a:solidFill>
-                  <a:srgbClr val="193048"/>
-                </a:solidFill>
-                <a:latin typeface="Aptos"/>
+                  <a:srgbClr val="163045"/>
+                </a:solidFill>
+                <a:latin typeface="Segoe UI"/>
               </a:defRPr>
             </a:pPr>
             <a:r>
-              <a:t>System design</a:t>
-            </a:r>
-          </a:p>
-        </p:txBody>
-      </p:sp>
-      <p:sp>
-        <p:nvSpPr>
-          <p:cNvPr id="8" name="Rectangle 7"/>
+              <a:t>One record, visible to both banks</a:t>
+            </a:r>
+          </a:p>
+        </p:txBody>
+      </p:sp>
+      <p:sp>
+        <p:nvSpPr>
+          <p:cNvPr id="9" name="TextBox 8"/>
+          <p:cNvSpPr txBox="1"/>
+          <p:nvPr/>
+        </p:nvSpPr>
+        <p:spPr>
+          <a:xfrm>
+            <a:off x="731520" y="1453896"/>
+            <a:ext cx="10698480" cy="384048"/>
+          </a:xfrm>
+          <a:prstGeom prst="rect">
+            <a:avLst/>
+          </a:prstGeom>
+          <a:noFill/>
+        </p:spPr>
+        <p:txBody>
+          <a:bodyPr wrap="square" lIns="18288" rIns="18288" tIns="9144" bIns="9144">
+            <a:spAutoFit/>
+          </a:bodyPr>
+          <a:lstStyle/>
+          <a:p>
+            <a:pPr algn="l">
+              <a:defRPr sz="1600" b="0">
+                <a:solidFill>
+                  <a:srgbClr val="667684"/>
+                </a:solidFill>
+                <a:latin typeface="Segoe UI"/>
+              </a:defRPr>
+            </a:pPr>
+            <a:r>
+              <a:t>The rule is checked by the smart contract, not by a single bank's interface.</a:t>
+            </a:r>
+          </a:p>
+        </p:txBody>
+      </p:sp>
+      <p:sp>
+        <p:nvSpPr>
+          <p:cNvPr id="10" name="Rectangle 9"/>
           <p:cNvSpPr/>
           <p:nvPr/>
         </p:nvSpPr>
         <p:spPr>
           <a:xfrm>
-            <a:off x="685800" y="1709928"/>
-            <a:ext cx="3383280" cy="1737360"/>
+            <a:off x="749808" y="2212848"/>
+            <a:ext cx="3246120" cy="2011680"/>
           </a:xfrm>
           <a:prstGeom prst="rect">
             <a:avLst/>
           </a:prstGeom>
           <a:solidFill>
-            <a:srgbClr val="EAF2F9"/>
+            <a:srgbClr val="FFFFFF"/>
           </a:solidFill>
           <a:ln>
             <a:solidFill>
-              <a:srgbClr val="D5DEE6"/>
+              <a:srgbClr val="D7E0E7"/>
             </a:solidFill>
           </a:ln>
         </p:spPr>
@@ -3890,97 +4120,23 @@
       </p:sp>
       <p:sp>
         <p:nvSpPr>
-          <p:cNvPr id="9" name="TextBox 8"/>
-          <p:cNvSpPr txBox="1"/>
-          <p:nvPr/>
-        </p:nvSpPr>
-        <p:spPr>
-          <a:xfrm>
-            <a:off x="896112" y="1947672"/>
-            <a:ext cx="2971800" cy="329184"/>
-          </a:xfrm>
-          <a:prstGeom prst="rect">
-            <a:avLst/>
-          </a:prstGeom>
-          <a:noFill/>
-        </p:spPr>
-        <p:txBody>
-          <a:bodyPr wrap="square" lIns="18288" rIns="18288" tIns="9144" bIns="9144">
-            <a:spAutoFit/>
-          </a:bodyPr>
-          <a:lstStyle/>
-          <a:p>
-            <a:pPr algn="l">
-              <a:defRPr sz="1600" b="1">
-                <a:solidFill>
-                  <a:srgbClr val="1B5B97"/>
-                </a:solidFill>
-                <a:latin typeface="Aptos"/>
-              </a:defRPr>
-            </a:pPr>
-            <a:r>
-              <a:t>BANK A</a:t>
-            </a:r>
-          </a:p>
-        </p:txBody>
-      </p:sp>
-      <p:sp>
-        <p:nvSpPr>
-          <p:cNvPr id="10" name="TextBox 9"/>
-          <p:cNvSpPr txBox="1"/>
-          <p:nvPr/>
-        </p:nvSpPr>
-        <p:spPr>
-          <a:xfrm>
-            <a:off x="896112" y="2441448"/>
-            <a:ext cx="2926080" cy="786384"/>
-          </a:xfrm>
-          <a:prstGeom prst="rect">
-            <a:avLst/>
-          </a:prstGeom>
-          <a:noFill/>
-        </p:spPr>
-        <p:txBody>
-          <a:bodyPr wrap="square" lIns="18288" rIns="18288" tIns="9144" bIns="9144">
-            <a:spAutoFit/>
-          </a:bodyPr>
-          <a:lstStyle/>
-          <a:p>
-            <a:pPr algn="l">
-              <a:defRPr sz="1700" b="0">
-                <a:solidFill>
-                  <a:srgbClr val="2F3A46"/>
-                </a:solidFill>
-                <a:latin typeface="Aptos"/>
-              </a:defRPr>
-            </a:pPr>
-            <a:r>
-              <a:t>Signs a transaction for a fictional donor code.</a:t>
-            </a:r>
-          </a:p>
-        </p:txBody>
-      </p:sp>
-      <p:sp>
-        <p:nvSpPr>
-          <p:cNvPr id="11" name="Rectangle 10"/>
+          <p:cNvPr id="11" name="Oval 10"/>
           <p:cNvSpPr/>
           <p:nvPr/>
         </p:nvSpPr>
         <p:spPr>
           <a:xfrm>
-            <a:off x="4526280" y="1709928"/>
-            <a:ext cx="3383280" cy="1737360"/>
-          </a:xfrm>
-          <a:prstGeom prst="rect">
+            <a:off x="978407" y="2450592"/>
+            <a:ext cx="502920" cy="502920"/>
+          </a:xfrm>
+          <a:prstGeom prst="ellipse">
             <a:avLst/>
           </a:prstGeom>
           <a:solidFill>
-            <a:srgbClr val="EAF2F9"/>
+            <a:srgbClr val="E8F5F2"/>
           </a:solidFill>
           <a:ln>
-            <a:solidFill>
-              <a:srgbClr val="D5DEE6"/>
-            </a:solidFill>
+            <a:noFill/>
           </a:ln>
         </p:spPr>
         <p:style>
@@ -4013,8 +4169,8 @@
         </p:nvSpPr>
         <p:spPr>
           <a:xfrm>
-            <a:off x="4736592" y="1947672"/>
-            <a:ext cx="2971800" cy="329184"/>
+            <a:off x="1014983" y="2587752"/>
+            <a:ext cx="420624" cy="201168"/>
           </a:xfrm>
           <a:prstGeom prst="rect">
             <a:avLst/>
@@ -4027,16 +4183,16 @@
           </a:bodyPr>
           <a:lstStyle/>
           <a:p>
-            <a:pPr algn="l">
-              <a:defRPr sz="1600" b="1">
-                <a:solidFill>
-                  <a:srgbClr val="1B5B97"/>
-                </a:solidFill>
-                <a:latin typeface="Aptos"/>
+            <a:pPr algn="ctr">
+              <a:defRPr sz="1100" b="1">
+                <a:solidFill>
+                  <a:srgbClr val="157E74"/>
+                </a:solidFill>
+                <a:latin typeface="Segoe UI"/>
               </a:defRPr>
             </a:pPr>
             <a:r>
-              <a:t>SMART CONTRACT</a:t>
+              <a:t>01</a:t>
             </a:r>
           </a:p>
         </p:txBody>
@@ -4049,8 +4205,8 @@
         </p:nvSpPr>
         <p:spPr>
           <a:xfrm>
-            <a:off x="4736592" y="2441448"/>
-            <a:ext cx="2926080" cy="786384"/>
+            <a:off x="1645919" y="2514600"/>
+            <a:ext cx="2148840" cy="310896"/>
           </a:xfrm>
           <a:prstGeom prst="rect">
             <a:avLst/>
@@ -4064,39 +4220,75 @@
           <a:lstStyle/>
           <a:p>
             <a:pPr algn="l">
-              <a:defRPr sz="1700" b="0">
-                <a:solidFill>
-                  <a:srgbClr val="2F3A46"/>
-                </a:solidFill>
-                <a:latin typeface="Aptos"/>
+              <a:defRPr sz="1600" b="1">
+                <a:solidFill>
+                  <a:srgbClr val="1C5484"/>
+                </a:solidFill>
+                <a:latin typeface="Segoe UI"/>
               </a:defRPr>
             </a:pPr>
             <a:r>
-              <a:t>Checks bank access and the recorded interval.</a:t>
-            </a:r>
-          </a:p>
-        </p:txBody>
-      </p:sp>
-      <p:sp>
-        <p:nvSpPr>
-          <p:cNvPr id="14" name="Rectangle 13"/>
+              <a:t>BANK A</a:t>
+            </a:r>
+          </a:p>
+        </p:txBody>
+      </p:sp>
+      <p:sp>
+        <p:nvSpPr>
+          <p:cNvPr id="14" name="TextBox 13"/>
+          <p:cNvSpPr txBox="1"/>
+          <p:nvPr/>
+        </p:nvSpPr>
+        <p:spPr>
+          <a:xfrm>
+            <a:off x="1005840" y="3099816"/>
+            <a:ext cx="2724912" cy="832104"/>
+          </a:xfrm>
+          <a:prstGeom prst="rect">
+            <a:avLst/>
+          </a:prstGeom>
+          <a:noFill/>
+        </p:spPr>
+        <p:txBody>
+          <a:bodyPr wrap="square" lIns="18288" rIns="18288" tIns="9144" bIns="9144">
+            <a:spAutoFit/>
+          </a:bodyPr>
+          <a:lstStyle/>
+          <a:p>
+            <a:pPr algn="l">
+              <a:defRPr sz="1800" b="0">
+                <a:solidFill>
+                  <a:srgbClr val="2A3A48"/>
+                </a:solidFill>
+                <a:latin typeface="Segoe UI"/>
+              </a:defRPr>
+            </a:pPr>
+            <a:r>
+              <a:t>Signs the first donation record in MetaMask.</a:t>
+            </a:r>
+          </a:p>
+        </p:txBody>
+      </p:sp>
+      <p:sp>
+        <p:nvSpPr>
+          <p:cNvPr id="15" name="Rectangle 14"/>
           <p:cNvSpPr/>
           <p:nvPr/>
         </p:nvSpPr>
         <p:spPr>
           <a:xfrm>
-            <a:off x="8366760" y="1709928"/>
-            <a:ext cx="3383280" cy="1737360"/>
+            <a:off x="4544568" y="2212848"/>
+            <a:ext cx="3246120" cy="2011680"/>
           </a:xfrm>
           <a:prstGeom prst="rect">
             <a:avLst/>
           </a:prstGeom>
           <a:solidFill>
-            <a:srgbClr val="EAF2F9"/>
+            <a:srgbClr val="FFFFFF"/>
           </a:solidFill>
           <a:ln>
             <a:solidFill>
-              <a:srgbClr val="D5DEE6"/>
+              <a:srgbClr val="D7E0E7"/>
             </a:solidFill>
           </a:ln>
         </p:spPr>
@@ -4124,169 +4316,23 @@
       </p:sp>
       <p:sp>
         <p:nvSpPr>
-          <p:cNvPr id="15" name="TextBox 14"/>
-          <p:cNvSpPr txBox="1"/>
-          <p:nvPr/>
-        </p:nvSpPr>
-        <p:spPr>
-          <a:xfrm>
-            <a:off x="8577072" y="1947672"/>
-            <a:ext cx="2971800" cy="329184"/>
-          </a:xfrm>
-          <a:prstGeom prst="rect">
-            <a:avLst/>
-          </a:prstGeom>
-          <a:noFill/>
-        </p:spPr>
-        <p:txBody>
-          <a:bodyPr wrap="square" lIns="18288" rIns="18288" tIns="9144" bIns="9144">
-            <a:spAutoFit/>
-          </a:bodyPr>
-          <a:lstStyle/>
-          <a:p>
-            <a:pPr algn="l">
-              <a:defRPr sz="1600" b="1">
-                <a:solidFill>
-                  <a:srgbClr val="1B5B97"/>
-                </a:solidFill>
-                <a:latin typeface="Aptos"/>
-              </a:defRPr>
-            </a:pPr>
-            <a:r>
-              <a:t>BANK B</a:t>
-            </a:r>
-          </a:p>
-        </p:txBody>
-      </p:sp>
-      <p:sp>
-        <p:nvSpPr>
-          <p:cNvPr id="16" name="TextBox 15"/>
-          <p:cNvSpPr txBox="1"/>
-          <p:nvPr/>
-        </p:nvSpPr>
-        <p:spPr>
-          <a:xfrm>
-            <a:off x="8577072" y="2441448"/>
-            <a:ext cx="2926080" cy="786384"/>
-          </a:xfrm>
-          <a:prstGeom prst="rect">
-            <a:avLst/>
-          </a:prstGeom>
-          <a:noFill/>
-        </p:spPr>
-        <p:txBody>
-          <a:bodyPr wrap="square" lIns="18288" rIns="18288" tIns="9144" bIns="9144">
-            <a:spAutoFit/>
-          </a:bodyPr>
-          <a:lstStyle/>
-          <a:p>
-            <a:pPr algn="l">
-              <a:defRPr sz="1700" b="0">
-                <a:solidFill>
-                  <a:srgbClr val="2F3A46"/>
-                </a:solidFill>
-                <a:latin typeface="Aptos"/>
-              </a:defRPr>
-            </a:pPr>
-            <a:r>
-              <a:t>Reads the same history before submitting a record.</a:t>
-            </a:r>
-          </a:p>
-        </p:txBody>
-      </p:sp>
-      <p:sp>
-        <p:nvSpPr>
-          <p:cNvPr id="17" name="TextBox 16"/>
-          <p:cNvSpPr txBox="1"/>
-          <p:nvPr/>
-        </p:nvSpPr>
-        <p:spPr>
-          <a:xfrm>
-            <a:off x="4133087" y="2313432"/>
-            <a:ext cx="329184" cy="502920"/>
-          </a:xfrm>
-          <a:prstGeom prst="rect">
-            <a:avLst/>
-          </a:prstGeom>
-          <a:noFill/>
-        </p:spPr>
-        <p:txBody>
-          <a:bodyPr wrap="square" lIns="18288" rIns="18288" tIns="9144" bIns="9144">
-            <a:spAutoFit/>
-          </a:bodyPr>
-          <a:lstStyle/>
-          <a:p>
-            <a:pPr algn="l">
-              <a:defRPr sz="2900" b="1">
-                <a:solidFill>
-                  <a:srgbClr val="1B5B97"/>
-                </a:solidFill>
-                <a:latin typeface="Aptos"/>
-              </a:defRPr>
-            </a:pPr>
-            <a:r>
-              <a:t>→</a:t>
-            </a:r>
-          </a:p>
-        </p:txBody>
-      </p:sp>
-      <p:sp>
-        <p:nvSpPr>
-          <p:cNvPr id="18" name="TextBox 17"/>
-          <p:cNvSpPr txBox="1"/>
-          <p:nvPr/>
-        </p:nvSpPr>
-        <p:spPr>
-          <a:xfrm>
-            <a:off x="7982712" y="2313432"/>
-            <a:ext cx="329184" cy="502920"/>
-          </a:xfrm>
-          <a:prstGeom prst="rect">
-            <a:avLst/>
-          </a:prstGeom>
-          <a:noFill/>
-        </p:spPr>
-        <p:txBody>
-          <a:bodyPr wrap="square" lIns="18288" rIns="18288" tIns="9144" bIns="9144">
-            <a:spAutoFit/>
-          </a:bodyPr>
-          <a:lstStyle/>
-          <a:p>
-            <a:pPr algn="l">
-              <a:defRPr sz="2900" b="1">
-                <a:solidFill>
-                  <a:srgbClr val="1B5B97"/>
-                </a:solidFill>
-                <a:latin typeface="Aptos"/>
-              </a:defRPr>
-            </a:pPr>
-            <a:r>
-              <a:t>→</a:t>
-            </a:r>
-          </a:p>
-        </p:txBody>
-      </p:sp>
-      <p:sp>
-        <p:nvSpPr>
-          <p:cNvPr id="19" name="Rectangle 18"/>
+          <p:cNvPr id="16" name="Oval 15"/>
           <p:cNvSpPr/>
           <p:nvPr/>
         </p:nvSpPr>
         <p:spPr>
           <a:xfrm>
-            <a:off x="685800" y="3995928"/>
-            <a:ext cx="10881360" cy="1325880"/>
-          </a:xfrm>
-          <a:prstGeom prst="rect">
+            <a:off x="4773168" y="2450592"/>
+            <a:ext cx="502920" cy="502920"/>
+          </a:xfrm>
+          <a:prstGeom prst="ellipse">
             <a:avLst/>
           </a:prstGeom>
           <a:solidFill>
-            <a:srgbClr val="FFFFFF"/>
+            <a:srgbClr val="E8F5F2"/>
           </a:solidFill>
           <a:ln>
-            <a:solidFill>
-              <a:srgbClr val="D5DEE6"/>
-            </a:solidFill>
+            <a:noFill/>
           </a:ln>
         </p:spPr>
         <p:style>
@@ -4313,14 +4359,14 @@
       </p:sp>
       <p:sp>
         <p:nvSpPr>
-          <p:cNvPr id="20" name="TextBox 19"/>
+          <p:cNvPr id="17" name="TextBox 16"/>
           <p:cNvSpPr txBox="1"/>
           <p:nvPr/>
         </p:nvSpPr>
         <p:spPr>
           <a:xfrm>
-            <a:off x="923544" y="4206240"/>
-            <a:ext cx="1920240" cy="347472"/>
+            <a:off x="4809744" y="2587752"/>
+            <a:ext cx="420624" cy="201168"/>
           </a:xfrm>
           <a:prstGeom prst="rect">
             <a:avLst/>
@@ -4333,30 +4379,30 @@
           </a:bodyPr>
           <a:lstStyle/>
           <a:p>
-            <a:pPr algn="l">
-              <a:defRPr sz="1600" b="1">
-                <a:solidFill>
-                  <a:srgbClr val="193048"/>
-                </a:solidFill>
-                <a:latin typeface="Aptos"/>
+            <a:pPr algn="ctr">
+              <a:defRPr sz="1100" b="1">
+                <a:solidFill>
+                  <a:srgbClr val="157E74"/>
+                </a:solidFill>
+                <a:latin typeface="Segoe UI"/>
               </a:defRPr>
             </a:pPr>
             <a:r>
-              <a:t>Contract rule</a:t>
-            </a:r>
-          </a:p>
-        </p:txBody>
-      </p:sp>
-      <p:sp>
-        <p:nvSpPr>
-          <p:cNvPr id="21" name="TextBox 20"/>
+              <a:t>02</a:t>
+            </a:r>
+          </a:p>
+        </p:txBody>
+      </p:sp>
+      <p:sp>
+        <p:nvSpPr>
+          <p:cNvPr id="18" name="TextBox 17"/>
           <p:cNvSpPr txBox="1"/>
           <p:nvPr/>
         </p:nvSpPr>
         <p:spPr>
           <a:xfrm>
-            <a:off x="2852928" y="4178808"/>
-            <a:ext cx="8321040" cy="502920"/>
+            <a:off x="5440680" y="2514600"/>
+            <a:ext cx="2148840" cy="310896"/>
           </a:xfrm>
           <a:prstGeom prst="rect">
             <a:avLst/>
@@ -4370,29 +4416,29 @@
           <a:lstStyle/>
           <a:p>
             <a:pPr algn="l">
-              <a:defRPr sz="1900" b="0">
-                <a:solidFill>
-                  <a:srgbClr val="2F3A46"/>
-                </a:solidFill>
-                <a:latin typeface="Aptos"/>
+              <a:defRPr sz="1600" b="1">
+                <a:solidFill>
+                  <a:srgbClr val="1C5484"/>
+                </a:solidFill>
+                <a:latin typeface="Segoe UI"/>
               </a:defRPr>
             </a:pPr>
             <a:r>
-              <a:t>A second record for the same code is rejected within 124 days.</a:t>
-            </a:r>
-          </a:p>
-        </p:txBody>
-      </p:sp>
-      <p:sp>
-        <p:nvSpPr>
-          <p:cNvPr id="22" name="TextBox 21"/>
+              <a:t>SMART CONTRACT</a:t>
+            </a:r>
+          </a:p>
+        </p:txBody>
+      </p:sp>
+      <p:sp>
+        <p:nvSpPr>
+          <p:cNvPr id="19" name="TextBox 18"/>
           <p:cNvSpPr txBox="1"/>
           <p:nvPr/>
         </p:nvSpPr>
         <p:spPr>
           <a:xfrm>
-            <a:off x="704088" y="5724144"/>
-            <a:ext cx="10789920" cy="384048"/>
+            <a:off x="4800600" y="3099816"/>
+            <a:ext cx="2724912" cy="832104"/>
           </a:xfrm>
           <a:prstGeom prst="rect">
             <a:avLst/>
@@ -4406,29 +4452,117 @@
           <a:lstStyle/>
           <a:p>
             <a:pPr algn="l">
-              <a:defRPr sz="1400" b="0">
-                <a:solidFill>
-                  <a:srgbClr val="616F7C"/>
-                </a:solidFill>
-                <a:latin typeface="Aptos"/>
+              <a:defRPr sz="1800" b="0">
+                <a:solidFill>
+                  <a:srgbClr val="2A3A48"/>
+                </a:solidFill>
+                <a:latin typeface="Segoe UI"/>
               </a:defRPr>
             </a:pPr>
             <a:r>
-              <a:t>The code is hashed before submission. Identity and medical data stay off-chain.</a:t>
-            </a:r>
-          </a:p>
-        </p:txBody>
-      </p:sp>
-      <p:sp>
-        <p:nvSpPr>
-          <p:cNvPr id="23" name="TextBox 22"/>
+              <a:t>Stores a timestamp and checks the interval.</a:t>
+            </a:r>
+          </a:p>
+        </p:txBody>
+      </p:sp>
+      <p:sp>
+        <p:nvSpPr>
+          <p:cNvPr id="20" name="Rectangle 19"/>
+          <p:cNvSpPr/>
+          <p:nvPr/>
+        </p:nvSpPr>
+        <p:spPr>
+          <a:xfrm>
+            <a:off x="8339328" y="2212848"/>
+            <a:ext cx="3246120" cy="2011680"/>
+          </a:xfrm>
+          <a:prstGeom prst="rect">
+            <a:avLst/>
+          </a:prstGeom>
+          <a:solidFill>
+            <a:srgbClr val="FFFFFF"/>
+          </a:solidFill>
+          <a:ln>
+            <a:solidFill>
+              <a:srgbClr val="D7E0E7"/>
+            </a:solidFill>
+          </a:ln>
+        </p:spPr>
+        <p:style>
+          <a:lnRef idx="1">
+            <a:schemeClr val="accent1"/>
+          </a:lnRef>
+          <a:fillRef idx="3">
+            <a:schemeClr val="accent1"/>
+          </a:fillRef>
+          <a:effectRef idx="2">
+            <a:schemeClr val="accent1"/>
+          </a:effectRef>
+          <a:fontRef idx="minor">
+            <a:schemeClr val="lt1"/>
+          </a:fontRef>
+        </p:style>
+        <p:txBody>
+          <a:bodyPr rtlCol="0" anchor="ctr"/>
+          <a:lstStyle/>
+          <a:p>
+            <a:pPr algn="ctr"/>
+          </a:p>
+        </p:txBody>
+      </p:sp>
+      <p:sp>
+        <p:nvSpPr>
+          <p:cNvPr id="21" name="Oval 20"/>
+          <p:cNvSpPr/>
+          <p:nvPr/>
+        </p:nvSpPr>
+        <p:spPr>
+          <a:xfrm>
+            <a:off x="8567928" y="2450592"/>
+            <a:ext cx="502920" cy="502920"/>
+          </a:xfrm>
+          <a:prstGeom prst="ellipse">
+            <a:avLst/>
+          </a:prstGeom>
+          <a:solidFill>
+            <a:srgbClr val="E8F5F2"/>
+          </a:solidFill>
+          <a:ln>
+            <a:noFill/>
+          </a:ln>
+        </p:spPr>
+        <p:style>
+          <a:lnRef idx="1">
+            <a:schemeClr val="accent1"/>
+          </a:lnRef>
+          <a:fillRef idx="3">
+            <a:schemeClr val="accent1"/>
+          </a:fillRef>
+          <a:effectRef idx="2">
+            <a:schemeClr val="accent1"/>
+          </a:effectRef>
+          <a:fontRef idx="minor">
+            <a:schemeClr val="lt1"/>
+          </a:fontRef>
+        </p:style>
+        <p:txBody>
+          <a:bodyPr rtlCol="0" anchor="ctr"/>
+          <a:lstStyle/>
+          <a:p>
+            <a:pPr algn="ctr"/>
+          </a:p>
+        </p:txBody>
+      </p:sp>
+      <p:sp>
+        <p:nvSpPr>
+          <p:cNvPr id="22" name="TextBox 21"/>
           <p:cNvSpPr txBox="1"/>
           <p:nvPr/>
         </p:nvSpPr>
         <p:spPr>
           <a:xfrm>
-            <a:off x="704088" y="6117336"/>
-            <a:ext cx="10789920" cy="228600"/>
+            <a:off x="8604504" y="2587752"/>
+            <a:ext cx="420624" cy="201168"/>
           </a:xfrm>
           <a:prstGeom prst="rect">
             <a:avLst/>
@@ -4441,16 +4575,311 @@
           </a:bodyPr>
           <a:lstStyle/>
           <a:p>
+            <a:pPr algn="ctr">
+              <a:defRPr sz="1100" b="1">
+                <a:solidFill>
+                  <a:srgbClr val="157E74"/>
+                </a:solidFill>
+                <a:latin typeface="Segoe UI"/>
+              </a:defRPr>
+            </a:pPr>
+            <a:r>
+              <a:t>03</a:t>
+            </a:r>
+          </a:p>
+        </p:txBody>
+      </p:sp>
+      <p:sp>
+        <p:nvSpPr>
+          <p:cNvPr id="23" name="TextBox 22"/>
+          <p:cNvSpPr txBox="1"/>
+          <p:nvPr/>
+        </p:nvSpPr>
+        <p:spPr>
+          <a:xfrm>
+            <a:off x="9235440" y="2514600"/>
+            <a:ext cx="2148840" cy="310896"/>
+          </a:xfrm>
+          <a:prstGeom prst="rect">
+            <a:avLst/>
+          </a:prstGeom>
+          <a:noFill/>
+        </p:spPr>
+        <p:txBody>
+          <a:bodyPr wrap="square" lIns="18288" rIns="18288" tIns="9144" bIns="9144">
+            <a:spAutoFit/>
+          </a:bodyPr>
+          <a:lstStyle/>
+          <a:p>
             <a:pPr algn="l">
-              <a:defRPr sz="1000" b="0">
-                <a:solidFill>
-                  <a:srgbClr val="616F7C"/>
-                </a:solidFill>
-                <a:latin typeface="Aptos"/>
+              <a:defRPr sz="1600" b="1">
+                <a:solidFill>
+                  <a:srgbClr val="1C5484"/>
+                </a:solidFill>
+                <a:latin typeface="Segoe UI"/>
               </a:defRPr>
             </a:pPr>
             <a:r>
-              <a:t>Interval reference: Sri Lanka National Blood Transfusion Service (nbts.health.gov.lk)</a:t>
+              <a:t>BANK B</a:t>
+            </a:r>
+          </a:p>
+        </p:txBody>
+      </p:sp>
+      <p:sp>
+        <p:nvSpPr>
+          <p:cNvPr id="24" name="TextBox 23"/>
+          <p:cNvSpPr txBox="1"/>
+          <p:nvPr/>
+        </p:nvSpPr>
+        <p:spPr>
+          <a:xfrm>
+            <a:off x="8595360" y="3099816"/>
+            <a:ext cx="2724912" cy="832104"/>
+          </a:xfrm>
+          <a:prstGeom prst="rect">
+            <a:avLst/>
+          </a:prstGeom>
+          <a:noFill/>
+        </p:spPr>
+        <p:txBody>
+          <a:bodyPr wrap="square" lIns="18288" rIns="18288" tIns="9144" bIns="9144">
+            <a:spAutoFit/>
+          </a:bodyPr>
+          <a:lstStyle/>
+          <a:p>
+            <a:pPr algn="l">
+              <a:defRPr sz="1800" b="0">
+                <a:solidFill>
+                  <a:srgbClr val="2A3A48"/>
+                </a:solidFill>
+                <a:latin typeface="Segoe UI"/>
+              </a:defRPr>
+            </a:pPr>
+            <a:r>
+              <a:t>Reads that record before another submission.</a:t>
+            </a:r>
+          </a:p>
+        </p:txBody>
+      </p:sp>
+      <p:sp>
+        <p:nvSpPr>
+          <p:cNvPr id="25" name="TextBox 24"/>
+          <p:cNvSpPr txBox="1"/>
+          <p:nvPr/>
+        </p:nvSpPr>
+        <p:spPr>
+          <a:xfrm>
+            <a:off x="4069080" y="2880360"/>
+            <a:ext cx="320040" cy="502920"/>
+          </a:xfrm>
+          <a:prstGeom prst="rect">
+            <a:avLst/>
+          </a:prstGeom>
+          <a:noFill/>
+        </p:spPr>
+        <p:txBody>
+          <a:bodyPr wrap="square" lIns="18288" rIns="18288" tIns="9144" bIns="9144">
+            <a:spAutoFit/>
+          </a:bodyPr>
+          <a:lstStyle/>
+          <a:p>
+            <a:pPr algn="l">
+              <a:defRPr sz="2700" b="1">
+                <a:solidFill>
+                  <a:srgbClr val="157E74"/>
+                </a:solidFill>
+                <a:latin typeface="Segoe UI"/>
+              </a:defRPr>
+            </a:pPr>
+            <a:r>
+              <a:t>→</a:t>
+            </a:r>
+          </a:p>
+        </p:txBody>
+      </p:sp>
+      <p:sp>
+        <p:nvSpPr>
+          <p:cNvPr id="26" name="TextBox 25"/>
+          <p:cNvSpPr txBox="1"/>
+          <p:nvPr/>
+        </p:nvSpPr>
+        <p:spPr>
+          <a:xfrm>
+            <a:off x="7872983" y="2880360"/>
+            <a:ext cx="320040" cy="502920"/>
+          </a:xfrm>
+          <a:prstGeom prst="rect">
+            <a:avLst/>
+          </a:prstGeom>
+          <a:noFill/>
+        </p:spPr>
+        <p:txBody>
+          <a:bodyPr wrap="square" lIns="18288" rIns="18288" tIns="9144" bIns="9144">
+            <a:spAutoFit/>
+          </a:bodyPr>
+          <a:lstStyle/>
+          <a:p>
+            <a:pPr algn="l">
+              <a:defRPr sz="2700" b="1">
+                <a:solidFill>
+                  <a:srgbClr val="157E74"/>
+                </a:solidFill>
+                <a:latin typeface="Segoe UI"/>
+              </a:defRPr>
+            </a:pPr>
+            <a:r>
+              <a:t>→</a:t>
+            </a:r>
+          </a:p>
+        </p:txBody>
+      </p:sp>
+      <p:sp>
+        <p:nvSpPr>
+          <p:cNvPr id="27" name="Rectangle 26"/>
+          <p:cNvSpPr/>
+          <p:nvPr/>
+        </p:nvSpPr>
+        <p:spPr>
+          <a:xfrm>
+            <a:off x="749808" y="4590288"/>
+            <a:ext cx="10835640" cy="1014984"/>
+          </a:xfrm>
+          <a:prstGeom prst="rect">
+            <a:avLst/>
+          </a:prstGeom>
+          <a:solidFill>
+            <a:srgbClr val="163045"/>
+          </a:solidFill>
+          <a:ln>
+            <a:noFill/>
+          </a:ln>
+        </p:spPr>
+        <p:style>
+          <a:lnRef idx="1">
+            <a:schemeClr val="accent1"/>
+          </a:lnRef>
+          <a:fillRef idx="3">
+            <a:schemeClr val="accent1"/>
+          </a:fillRef>
+          <a:effectRef idx="2">
+            <a:schemeClr val="accent1"/>
+          </a:effectRef>
+          <a:fontRef idx="minor">
+            <a:schemeClr val="lt1"/>
+          </a:fontRef>
+        </p:style>
+        <p:txBody>
+          <a:bodyPr rtlCol="0" anchor="ctr"/>
+          <a:lstStyle/>
+          <a:p>
+            <a:pPr algn="ctr"/>
+          </a:p>
+        </p:txBody>
+      </p:sp>
+      <p:sp>
+        <p:nvSpPr>
+          <p:cNvPr id="28" name="TextBox 27"/>
+          <p:cNvSpPr txBox="1"/>
+          <p:nvPr/>
+        </p:nvSpPr>
+        <p:spPr>
+          <a:xfrm>
+            <a:off x="1024128" y="4828032"/>
+            <a:ext cx="2103120" cy="493776"/>
+          </a:xfrm>
+          <a:prstGeom prst="rect">
+            <a:avLst/>
+          </a:prstGeom>
+          <a:noFill/>
+        </p:spPr>
+        <p:txBody>
+          <a:bodyPr wrap="square" lIns="18288" rIns="18288" tIns="9144" bIns="9144">
+            <a:spAutoFit/>
+          </a:bodyPr>
+          <a:lstStyle/>
+          <a:p>
+            <a:pPr algn="l">
+              <a:defRPr sz="2500" b="1">
+                <a:solidFill>
+                  <a:srgbClr val="FFFFFF"/>
+                </a:solidFill>
+                <a:latin typeface="Segoe UI"/>
+              </a:defRPr>
+            </a:pPr>
+            <a:r>
+              <a:t>124 days</a:t>
+            </a:r>
+          </a:p>
+        </p:txBody>
+      </p:sp>
+      <p:sp>
+        <p:nvSpPr>
+          <p:cNvPr id="29" name="TextBox 28"/>
+          <p:cNvSpPr txBox="1"/>
+          <p:nvPr/>
+        </p:nvSpPr>
+        <p:spPr>
+          <a:xfrm>
+            <a:off x="3063240" y="4864608"/>
+            <a:ext cx="7955279" cy="411480"/>
+          </a:xfrm>
+          <a:prstGeom prst="rect">
+            <a:avLst/>
+          </a:prstGeom>
+          <a:noFill/>
+        </p:spPr>
+        <p:txBody>
+          <a:bodyPr wrap="square" lIns="18288" rIns="18288" tIns="9144" bIns="9144">
+            <a:spAutoFit/>
+          </a:bodyPr>
+          <a:lstStyle/>
+          <a:p>
+            <a:pPr algn="l">
+              <a:defRPr sz="1800" b="0">
+                <a:solidFill>
+                  <a:srgbClr val="FFFFFF"/>
+                </a:solidFill>
+                <a:latin typeface="Segoe UI"/>
+              </a:defRPr>
+            </a:pPr>
+            <a:r>
+              <a:t>Fixed interval before another record for the same code</a:t>
+            </a:r>
+          </a:p>
+        </p:txBody>
+      </p:sp>
+      <p:sp>
+        <p:nvSpPr>
+          <p:cNvPr id="30" name="TextBox 29"/>
+          <p:cNvSpPr txBox="1"/>
+          <p:nvPr/>
+        </p:nvSpPr>
+        <p:spPr>
+          <a:xfrm>
+            <a:off x="768096" y="5870448"/>
+            <a:ext cx="10652760" cy="256032"/>
+          </a:xfrm>
+          <a:prstGeom prst="rect">
+            <a:avLst/>
+          </a:prstGeom>
+          <a:noFill/>
+        </p:spPr>
+        <p:txBody>
+          <a:bodyPr wrap="square" lIns="18288" rIns="18288" tIns="9144" bIns="9144">
+            <a:spAutoFit/>
+          </a:bodyPr>
+          <a:lstStyle/>
+          <a:p>
+            <a:pPr algn="l">
+              <a:defRPr sz="1200" b="0">
+                <a:solidFill>
+                  <a:srgbClr val="667684"/>
+                </a:solidFill>
+                <a:latin typeface="Segoe UI"/>
+              </a:defRPr>
+            </a:pPr>
+            <a:r>
+              <a:t>Only a hash of the random code is submitted. Names and medical details remain off-chain.</a:t>
             </a:r>
           </a:p>
         </p:txBody>
@@ -4469,7 +4898,7 @@
     <p:bg>
       <p:bgPr>
         <a:solidFill>
-          <a:srgbClr val="FFFFFF"/>
+          <a:srgbClr val="F8FAFB"/>
         </a:solidFill>
         <a:effectLst/>
       </p:bgPr>
@@ -4490,13 +4919,13 @@
         <p:spPr>
           <a:xfrm>
             <a:off x="0" y="0"/>
-            <a:ext cx="12191695" cy="118872"/>
+            <a:ext cx="118872" cy="6858000"/>
           </a:xfrm>
           <a:prstGeom prst="rect">
             <a:avLst/>
           </a:prstGeom>
           <a:solidFill>
-            <a:srgbClr val="1B5B97"/>
+            <a:srgbClr val="157E74"/>
           </a:solidFill>
           <a:ln>
             <a:noFill/>
@@ -4532,8 +4961,8 @@
         </p:nvSpPr>
         <p:spPr>
           <a:xfrm>
-            <a:off x="640080" y="283464"/>
-            <a:ext cx="7772400" cy="274320"/>
+            <a:off x="667512" y="320040"/>
+            <a:ext cx="7315200" cy="246888"/>
           </a:xfrm>
           <a:prstGeom prst="rect">
             <a:avLst/>
@@ -4547,35 +4976,71 @@
           <a:lstStyle/>
           <a:p>
             <a:pPr algn="l">
-              <a:defRPr sz="1100" b="1">
-                <a:solidFill>
-                  <a:srgbClr val="1B5B97"/>
-                </a:solidFill>
-                <a:latin typeface="Aptos"/>
+              <a:defRPr sz="1000" b="1">
+                <a:solidFill>
+                  <a:srgbClr val="1C5484"/>
+                </a:solidFill>
+                <a:latin typeface="Segoe UI"/>
               </a:defRPr>
             </a:pPr>
             <a:r>
-              <a:t>EC8204  |  BLOCKCHAIN AND CYBER SECURITY</a:t>
-            </a:r>
-          </a:p>
-        </p:txBody>
-      </p:sp>
-      <p:sp>
-        <p:nvSpPr>
-          <p:cNvPr id="4" name="Rectangle 3"/>
+              <a:t>EC8204  /  BLOCKCHAIN AND CYBER SECURITY</a:t>
+            </a:r>
+          </a:p>
+        </p:txBody>
+      </p:sp>
+      <p:sp>
+        <p:nvSpPr>
+          <p:cNvPr id="4" name="TextBox 3"/>
+          <p:cNvSpPr txBox="1"/>
+          <p:nvPr/>
+        </p:nvSpPr>
+        <p:spPr>
+          <a:xfrm>
+            <a:off x="9418320" y="320040"/>
+            <a:ext cx="2103120" cy="246888"/>
+          </a:xfrm>
+          <a:prstGeom prst="rect">
+            <a:avLst/>
+          </a:prstGeom>
+          <a:noFill/>
+        </p:spPr>
+        <p:txBody>
+          <a:bodyPr wrap="square" lIns="18288" rIns="18288" tIns="9144" bIns="9144">
+            <a:spAutoFit/>
+          </a:bodyPr>
+          <a:lstStyle/>
+          <a:p>
+            <a:pPr algn="r">
+              <a:defRPr sz="1000" b="1">
+                <a:solidFill>
+                  <a:srgbClr val="667684"/>
+                </a:solidFill>
+                <a:latin typeface="Segoe UI"/>
+              </a:defRPr>
+            </a:pPr>
+            <a:r>
+              <a:t>RESULTS</a:t>
+            </a:r>
+          </a:p>
+        </p:txBody>
+      </p:sp>
+      <p:sp>
+        <p:nvSpPr>
+          <p:cNvPr id="5" name="Rectangle 4"/>
           <p:cNvSpPr/>
           <p:nvPr/>
         </p:nvSpPr>
         <p:spPr>
           <a:xfrm>
-            <a:off x="640080" y="6419088"/>
-            <a:ext cx="10881360" cy="10972"/>
+            <a:off x="685800" y="6336792"/>
+            <a:ext cx="10835640" cy="13716"/>
           </a:xfrm>
           <a:prstGeom prst="rect">
             <a:avLst/>
           </a:prstGeom>
           <a:solidFill>
-            <a:srgbClr val="D5DEE6"/>
+            <a:srgbClr val="D7E0E7"/>
           </a:solidFill>
           <a:ln>
             <a:noFill/>
@@ -4605,14 +5070,14 @@
       </p:sp>
       <p:sp>
         <p:nvSpPr>
-          <p:cNvPr id="5" name="TextBox 4"/>
+          <p:cNvPr id="6" name="TextBox 5"/>
           <p:cNvSpPr txBox="1"/>
           <p:nvPr/>
         </p:nvSpPr>
         <p:spPr>
           <a:xfrm>
-            <a:off x="658368" y="6473952"/>
-            <a:ext cx="5486400" cy="210312"/>
+            <a:off x="694944" y="6437376"/>
+            <a:ext cx="5303520" cy="210312"/>
           </a:xfrm>
           <a:prstGeom prst="rect">
             <a:avLst/>
@@ -4628,27 +5093,27 @@
             <a:pPr algn="l">
               <a:defRPr sz="900" b="0">
                 <a:solidFill>
-                  <a:srgbClr val="616F7C"/>
-                </a:solidFill>
-                <a:latin typeface="Aptos"/>
+                  <a:srgbClr val="667684"/>
+                </a:solidFill>
+                <a:latin typeface="Segoe UI"/>
               </a:defRPr>
             </a:pPr>
             <a:r>
-              <a:t>GROUP 40  |  DONORINTERVAL</a:t>
-            </a:r>
-          </a:p>
-        </p:txBody>
-      </p:sp>
-      <p:sp>
-        <p:nvSpPr>
-          <p:cNvPr id="6" name="TextBox 5"/>
+              <a:t>GROUP 40 · DONORINTERVAL</a:t>
+            </a:r>
+          </a:p>
+        </p:txBody>
+      </p:sp>
+      <p:sp>
+        <p:nvSpPr>
+          <p:cNvPr id="7" name="TextBox 6"/>
           <p:cNvSpPr txBox="1"/>
           <p:nvPr/>
         </p:nvSpPr>
         <p:spPr>
           <a:xfrm>
-            <a:off x="10972800" y="6473952"/>
-            <a:ext cx="502920" cy="210312"/>
+            <a:off x="10789920" y="6437376"/>
+            <a:ext cx="731520" cy="210312"/>
           </a:xfrm>
           <a:prstGeom prst="rect">
             <a:avLst/>
@@ -4664,27 +5129,27 @@
             <a:pPr algn="r">
               <a:defRPr sz="900" b="0">
                 <a:solidFill>
-                  <a:srgbClr val="616F7C"/>
-                </a:solidFill>
-                <a:latin typeface="Aptos"/>
+                  <a:srgbClr val="667684"/>
+                </a:solidFill>
+                <a:latin typeface="Segoe UI"/>
               </a:defRPr>
             </a:pPr>
             <a:r>
-              <a:t>3</a:t>
-            </a:r>
-          </a:p>
-        </p:txBody>
-      </p:sp>
-      <p:sp>
-        <p:nvSpPr>
-          <p:cNvPr id="7" name="TextBox 6"/>
+              <a:t>03 / 03</a:t>
+            </a:r>
+          </a:p>
+        </p:txBody>
+      </p:sp>
+      <p:sp>
+        <p:nvSpPr>
+          <p:cNvPr id="8" name="TextBox 7"/>
           <p:cNvSpPr txBox="1"/>
           <p:nvPr/>
         </p:nvSpPr>
         <p:spPr>
           <a:xfrm>
-            <a:off x="658368" y="786384"/>
-            <a:ext cx="10789920" cy="548640"/>
+            <a:off x="713232" y="896112"/>
+            <a:ext cx="10698480" cy="512064"/>
           </a:xfrm>
           <a:prstGeom prst="rect">
             <a:avLst/>
@@ -4700,38 +5165,36 @@
             <a:pPr algn="l">
               <a:defRPr sz="2900" b="1">
                 <a:solidFill>
-                  <a:srgbClr val="193048"/>
-                </a:solidFill>
-                <a:latin typeface="Aptos"/>
+                  <a:srgbClr val="163045"/>
+                </a:solidFill>
+                <a:latin typeface="Segoe UI"/>
               </a:defRPr>
             </a:pPr>
             <a:r>
-              <a:t>Results and limitations</a:t>
-            </a:r>
-          </a:p>
-        </p:txBody>
-      </p:sp>
-      <p:sp>
-        <p:nvSpPr>
-          <p:cNvPr id="8" name="Rectangle 7"/>
+              <a:t>What the prototype demonstrates</a:t>
+            </a:r>
+          </a:p>
+        </p:txBody>
+      </p:sp>
+      <p:sp>
+        <p:nvSpPr>
+          <p:cNvPr id="9" name="Rectangle 8"/>
           <p:cNvSpPr/>
           <p:nvPr/>
         </p:nvSpPr>
         <p:spPr>
           <a:xfrm>
-            <a:off x="685800" y="1664208"/>
-            <a:ext cx="5257800" cy="3950208"/>
+            <a:off x="749808" y="1691640"/>
+            <a:ext cx="4160520" cy="4050791"/>
           </a:xfrm>
           <a:prstGeom prst="rect">
             <a:avLst/>
           </a:prstGeom>
           <a:solidFill>
-            <a:srgbClr val="EAF2F9"/>
+            <a:srgbClr val="E8F5F2"/>
           </a:solidFill>
           <a:ln>
-            <a:solidFill>
-              <a:srgbClr val="D5DEE6"/>
-            </a:solidFill>
+            <a:noFill/>
           </a:ln>
         </p:spPr>
         <p:style>
@@ -4758,14 +5221,14 @@
       </p:sp>
       <p:sp>
         <p:nvSpPr>
-          <p:cNvPr id="9" name="TextBox 8"/>
+          <p:cNvPr id="10" name="TextBox 9"/>
           <p:cNvSpPr txBox="1"/>
           <p:nvPr/>
         </p:nvSpPr>
         <p:spPr>
           <a:xfrm>
-            <a:off x="941832" y="1901952"/>
-            <a:ext cx="4709160" cy="502920"/>
+            <a:off x="1033271" y="2002536"/>
+            <a:ext cx="3611880" cy="868680"/>
           </a:xfrm>
           <a:prstGeom prst="rect">
             <a:avLst/>
@@ -4779,29 +5242,29 @@
           <a:lstStyle/>
           <a:p>
             <a:pPr algn="l">
-              <a:defRPr sz="2400" b="1">
-                <a:solidFill>
-                  <a:srgbClr val="1B5B97"/>
-                </a:solidFill>
-                <a:latin typeface="Aptos"/>
+              <a:defRPr sz="4700" b="1">
+                <a:solidFill>
+                  <a:srgbClr val="157E74"/>
+                </a:solidFill>
+                <a:latin typeface="Segoe UI"/>
               </a:defRPr>
             </a:pPr>
             <a:r>
-              <a:t>8 passing tests</a:t>
-            </a:r>
-          </a:p>
-        </p:txBody>
-      </p:sp>
-      <p:sp>
-        <p:nvSpPr>
-          <p:cNvPr id="10" name="TextBox 9"/>
+              <a:t>8 / 8</a:t>
+            </a:r>
+          </a:p>
+        </p:txBody>
+      </p:sp>
+      <p:sp>
+        <p:nvSpPr>
+          <p:cNvPr id="11" name="TextBox 10"/>
           <p:cNvSpPr txBox="1"/>
           <p:nvPr/>
         </p:nvSpPr>
         <p:spPr>
           <a:xfrm>
-            <a:off x="941832" y="2660904"/>
-            <a:ext cx="4709160" cy="2560320"/>
+            <a:off x="1069848" y="2889504"/>
+            <a:ext cx="3547872" cy="457200"/>
           </a:xfrm>
           <a:prstGeom prst="rect">
             <a:avLst/>
@@ -4815,52 +5278,38 @@
           <a:lstStyle/>
           <a:p>
             <a:pPr algn="l">
-              <a:defRPr sz="1800" b="0">
-                <a:solidFill>
-                  <a:srgbClr val="2F3A46"/>
-                </a:solidFill>
-                <a:latin typeface="Aptos"/>
+              <a:defRPr sz="1800" b="1">
+                <a:solidFill>
+                  <a:srgbClr val="163045"/>
+                </a:solidFill>
+                <a:latin typeface="Segoe UI"/>
               </a:defRPr>
             </a:pPr>
             <a:r>
-              <a:t>• First donation recorded with a timestamp</a:t>
-            </a:r>
-            <a:br/>
-            <a:r>
-              <a:t>• Early second record blocked across banks</a:t>
-            </a:r>
-            <a:br/>
-            <a:r>
-              <a:t>• Unauthorized or revoked bank blocked</a:t>
-            </a:r>
-            <a:br/>
-            <a:r>
-              <a:t>• Later record accepted after simulated time</a:t>
-            </a:r>
-          </a:p>
-        </p:txBody>
-      </p:sp>
-      <p:sp>
-        <p:nvSpPr>
-          <p:cNvPr id="11" name="Rectangle 10"/>
+              <a:t>contract tests passing</a:t>
+            </a:r>
+          </a:p>
+        </p:txBody>
+      </p:sp>
+      <p:sp>
+        <p:nvSpPr>
+          <p:cNvPr id="12" name="Rectangle 11"/>
           <p:cNvSpPr/>
           <p:nvPr/>
         </p:nvSpPr>
         <p:spPr>
           <a:xfrm>
-            <a:off x="6217920" y="1664208"/>
-            <a:ext cx="5303520" cy="3950208"/>
+            <a:off x="1060704" y="3520440"/>
+            <a:ext cx="3401568" cy="14630"/>
           </a:xfrm>
           <a:prstGeom prst="rect">
             <a:avLst/>
           </a:prstGeom>
           <a:solidFill>
-            <a:srgbClr val="FFFFFF"/>
+            <a:srgbClr val="D7E0E7"/>
           </a:solidFill>
           <a:ln>
-            <a:solidFill>
-              <a:srgbClr val="D5DEE6"/>
-            </a:solidFill>
+            <a:noFill/>
           </a:ln>
         </p:spPr>
         <p:style>
@@ -4887,14 +5336,14 @@
       </p:sp>
       <p:sp>
         <p:nvSpPr>
-          <p:cNvPr id="12" name="TextBox 11"/>
+          <p:cNvPr id="13" name="TextBox 12"/>
           <p:cNvSpPr txBox="1"/>
           <p:nvPr/>
         </p:nvSpPr>
         <p:spPr>
           <a:xfrm>
-            <a:off x="6492240" y="1901952"/>
-            <a:ext cx="4663440" cy="457200"/>
+            <a:off x="1060704" y="3813048"/>
+            <a:ext cx="3502152" cy="1508760"/>
           </a:xfrm>
           <a:prstGeom prst="rect">
             <a:avLst/>
@@ -4908,29 +5357,82 @@
           <a:lstStyle/>
           <a:p>
             <a:pPr algn="l">
-              <a:defRPr sz="2200" b="1">
-                <a:solidFill>
-                  <a:srgbClr val="193048"/>
-                </a:solidFill>
-                <a:latin typeface="Aptos"/>
+              <a:defRPr sz="1700" b="0">
+                <a:solidFill>
+                  <a:srgbClr val="2A3A48"/>
+                </a:solidFill>
+                <a:latin typeface="Segoe UI"/>
               </a:defRPr>
             </a:pPr>
             <a:r>
-              <a:t>Important limits</a:t>
-            </a:r>
-          </a:p>
-        </p:txBody>
-      </p:sp>
-      <p:sp>
-        <p:nvSpPr>
-          <p:cNvPr id="13" name="TextBox 12"/>
+              <a:t>First record accepted</a:t>
+            </a:r>
+            <a:br/>
+            <a:r>
+              <a:t>Early second record rejected</a:t>
+            </a:r>
+            <a:br/>
+            <a:r>
+              <a:t>Bank authorization enforced</a:t>
+            </a:r>
+          </a:p>
+        </p:txBody>
+      </p:sp>
+      <p:sp>
+        <p:nvSpPr>
+          <p:cNvPr id="14" name="Rectangle 13"/>
+          <p:cNvSpPr/>
+          <p:nvPr/>
+        </p:nvSpPr>
+        <p:spPr>
+          <a:xfrm>
+            <a:off x="5175504" y="1691640"/>
+            <a:ext cx="6409944" cy="4050791"/>
+          </a:xfrm>
+          <a:prstGeom prst="rect">
+            <a:avLst/>
+          </a:prstGeom>
+          <a:solidFill>
+            <a:srgbClr val="FFFFFF"/>
+          </a:solidFill>
+          <a:ln>
+            <a:solidFill>
+              <a:srgbClr val="D7E0E7"/>
+            </a:solidFill>
+          </a:ln>
+        </p:spPr>
+        <p:style>
+          <a:lnRef idx="1">
+            <a:schemeClr val="accent1"/>
+          </a:lnRef>
+          <a:fillRef idx="3">
+            <a:schemeClr val="accent1"/>
+          </a:fillRef>
+          <a:effectRef idx="2">
+            <a:schemeClr val="accent1"/>
+          </a:effectRef>
+          <a:fontRef idx="minor">
+            <a:schemeClr val="lt1"/>
+          </a:fontRef>
+        </p:style>
+        <p:txBody>
+          <a:bodyPr rtlCol="0" anchor="ctr"/>
+          <a:lstStyle/>
+          <a:p>
+            <a:pPr algn="ctr"/>
+          </a:p>
+        </p:txBody>
+      </p:sp>
+      <p:sp>
+        <p:nvSpPr>
+          <p:cNvPr id="15" name="TextBox 14"/>
           <p:cNvSpPr txBox="1"/>
           <p:nvPr/>
         </p:nvSpPr>
         <p:spPr>
           <a:xfrm>
-            <a:off x="6492240" y="2670048"/>
-            <a:ext cx="4663440" cy="2286000"/>
+            <a:off x="5495544" y="1993392"/>
+            <a:ext cx="5724144" cy="411480"/>
           </a:xfrm>
           <a:prstGeom prst="rect">
             <a:avLst/>
@@ -4944,37 +5446,29 @@
           <a:lstStyle/>
           <a:p>
             <a:pPr algn="l">
-              <a:defRPr sz="1800" b="0">
-                <a:solidFill>
-                  <a:srgbClr val="2F3A46"/>
-                </a:solidFill>
-                <a:latin typeface="Aptos"/>
+              <a:defRPr sz="2100" b="1">
+                <a:solidFill>
+                  <a:srgbClr val="1C5484"/>
+                </a:solidFill>
+                <a:latin typeface="Segoe UI"/>
               </a:defRPr>
             </a:pPr>
             <a:r>
-              <a:t>• Only records on this contract are checked.</a:t>
-            </a:r>
-            <a:br/>
-            <a:r>
-              <a:t>• A known code can link public records.</a:t>
-            </a:r>
-            <a:br/>
-            <a:r>
-              <a:t>• Clinical staff decide donor eligibility.</a:t>
-            </a:r>
-          </a:p>
-        </p:txBody>
-      </p:sp>
-      <p:sp>
-        <p:nvSpPr>
-          <p:cNvPr id="14" name="TextBox 13"/>
+              <a:t>Scope and limitations</a:t>
+            </a:r>
+          </a:p>
+        </p:txBody>
+      </p:sp>
+      <p:sp>
+        <p:nvSpPr>
+          <p:cNvPr id="16" name="TextBox 15"/>
           <p:cNvSpPr txBox="1"/>
           <p:nvPr/>
         </p:nvSpPr>
         <p:spPr>
           <a:xfrm>
-            <a:off x="713232" y="5870448"/>
-            <a:ext cx="10881360" cy="320040"/>
+            <a:off x="5504688" y="2697480"/>
+            <a:ext cx="5577840" cy="393192"/>
           </a:xfrm>
           <a:prstGeom prst="rect">
             <a:avLst/>
@@ -4988,15 +5482,202 @@
           <a:lstStyle/>
           <a:p>
             <a:pPr algn="l">
+              <a:defRPr sz="1800" b="0">
+                <a:solidFill>
+                  <a:srgbClr val="2A3A48"/>
+                </a:solidFill>
+                <a:latin typeface="Segoe UI"/>
+              </a:defRPr>
+            </a:pPr>
+            <a:r>
+              <a:t>This checks records on this contract only.</a:t>
+            </a:r>
+          </a:p>
+        </p:txBody>
+      </p:sp>
+      <p:sp>
+        <p:nvSpPr>
+          <p:cNvPr id="17" name="TextBox 16"/>
+          <p:cNvSpPr txBox="1"/>
+          <p:nvPr/>
+        </p:nvSpPr>
+        <p:spPr>
+          <a:xfrm>
+            <a:off x="5504688" y="3383280"/>
+            <a:ext cx="5577840" cy="393192"/>
+          </a:xfrm>
+          <a:prstGeom prst="rect">
+            <a:avLst/>
+          </a:prstGeom>
+          <a:noFill/>
+        </p:spPr>
+        <p:txBody>
+          <a:bodyPr wrap="square" lIns="18288" rIns="18288" tIns="9144" bIns="9144">
+            <a:spAutoFit/>
+          </a:bodyPr>
+          <a:lstStyle/>
+          <a:p>
+            <a:pPr algn="l">
+              <a:defRPr sz="1800" b="0">
+                <a:solidFill>
+                  <a:srgbClr val="2A3A48"/>
+                </a:solidFill>
+                <a:latin typeface="Segoe UI"/>
+              </a:defRPr>
+            </a:pPr>
+            <a:r>
+              <a:t>A disclosed code can link public records.</a:t>
+            </a:r>
+          </a:p>
+        </p:txBody>
+      </p:sp>
+      <p:sp>
+        <p:nvSpPr>
+          <p:cNvPr id="18" name="TextBox 17"/>
+          <p:cNvSpPr txBox="1"/>
+          <p:nvPr/>
+        </p:nvSpPr>
+        <p:spPr>
+          <a:xfrm>
+            <a:off x="5504688" y="4069080"/>
+            <a:ext cx="5577840" cy="393192"/>
+          </a:xfrm>
+          <a:prstGeom prst="rect">
+            <a:avLst/>
+          </a:prstGeom>
+          <a:noFill/>
+        </p:spPr>
+        <p:txBody>
+          <a:bodyPr wrap="square" lIns="18288" rIns="18288" tIns="9144" bIns="9144">
+            <a:spAutoFit/>
+          </a:bodyPr>
+          <a:lstStyle/>
+          <a:p>
+            <a:pPr algn="l">
+              <a:defRPr sz="1800" b="0">
+                <a:solidFill>
+                  <a:srgbClr val="2A3A48"/>
+                </a:solidFill>
+                <a:latin typeface="Segoe UI"/>
+              </a:defRPr>
+            </a:pPr>
+            <a:r>
+              <a:t>Clinical staff still decide donor eligibility.</a:t>
+            </a:r>
+          </a:p>
+        </p:txBody>
+      </p:sp>
+      <p:sp>
+        <p:nvSpPr>
+          <p:cNvPr id="19" name="Rectangle 18"/>
+          <p:cNvSpPr/>
+          <p:nvPr/>
+        </p:nvSpPr>
+        <p:spPr>
+          <a:xfrm>
+            <a:off x="5495544" y="4828032"/>
+            <a:ext cx="5458968" cy="27432"/>
+          </a:xfrm>
+          <a:prstGeom prst="rect">
+            <a:avLst/>
+          </a:prstGeom>
+          <a:solidFill>
+            <a:srgbClr val="157E74"/>
+          </a:solidFill>
+          <a:ln>
+            <a:noFill/>
+          </a:ln>
+        </p:spPr>
+        <p:style>
+          <a:lnRef idx="1">
+            <a:schemeClr val="accent1"/>
+          </a:lnRef>
+          <a:fillRef idx="3">
+            <a:schemeClr val="accent1"/>
+          </a:fillRef>
+          <a:effectRef idx="2">
+            <a:schemeClr val="accent1"/>
+          </a:effectRef>
+          <a:fontRef idx="minor">
+            <a:schemeClr val="lt1"/>
+          </a:fontRef>
+        </p:style>
+        <p:txBody>
+          <a:bodyPr rtlCol="0" anchor="ctr"/>
+          <a:lstStyle/>
+          <a:p>
+            <a:pPr algn="ctr"/>
+          </a:p>
+        </p:txBody>
+      </p:sp>
+      <p:sp>
+        <p:nvSpPr>
+          <p:cNvPr id="20" name="TextBox 19"/>
+          <p:cNvSpPr txBox="1"/>
+          <p:nvPr/>
+        </p:nvSpPr>
+        <p:spPr>
+          <a:xfrm>
+            <a:off x="5504688" y="5038344"/>
+            <a:ext cx="5577840" cy="402336"/>
+          </a:xfrm>
+          <a:prstGeom prst="rect">
+            <a:avLst/>
+          </a:prstGeom>
+          <a:noFill/>
+        </p:spPr>
+        <p:txBody>
+          <a:bodyPr wrap="square" lIns="18288" rIns="18288" tIns="9144" bIns="9144">
+            <a:spAutoFit/>
+          </a:bodyPr>
+          <a:lstStyle/>
+          <a:p>
+            <a:pPr algn="l">
               <a:defRPr sz="1300" b="0">
                 <a:solidFill>
-                  <a:srgbClr val="995D16"/>
-                </a:solidFill>
-                <a:latin typeface="Aptos"/>
+                  <a:srgbClr val="97601E"/>
+                </a:solidFill>
+                <a:latin typeface="Segoe UI"/>
               </a:defRPr>
             </a:pPr>
             <a:r>
-              <a:t>The 124-day rule is a fixed demonstration approximation, not a clinical decision.</a:t>
+              <a:t>The 124-day rule is a fixed demonstration approximation.</a:t>
+            </a:r>
+          </a:p>
+        </p:txBody>
+      </p:sp>
+      <p:sp>
+        <p:nvSpPr>
+          <p:cNvPr id="21" name="TextBox 20"/>
+          <p:cNvSpPr txBox="1"/>
+          <p:nvPr/>
+        </p:nvSpPr>
+        <p:spPr>
+          <a:xfrm>
+            <a:off x="768096" y="5961888"/>
+            <a:ext cx="10698480" cy="237744"/>
+          </a:xfrm>
+          <a:prstGeom prst="rect">
+            <a:avLst/>
+          </a:prstGeom>
+          <a:noFill/>
+        </p:spPr>
+        <p:txBody>
+          <a:bodyPr wrap="square" lIns="18288" rIns="18288" tIns="9144" bIns="9144">
+            <a:spAutoFit/>
+          </a:bodyPr>
+          <a:lstStyle/>
+          <a:p>
+            <a:pPr algn="l">
+              <a:defRPr sz="1000" b="0">
+                <a:solidFill>
+                  <a:srgbClr val="667684"/>
+                </a:solidFill>
+                <a:latin typeface="Segoe UI"/>
+              </a:defRPr>
+            </a:pPr>
+            <a:r>
+              <a:t>Interval reference: Sri Lanka National Blood Transfusion Service · nbts.health.gov.lk</a:t>
             </a:r>
           </a:p>
         </p:txBody>

</xml_diff>